<commit_message>
Use app launcher icon in PPT; closing line powered by Team Genesis
Replace YatraWise wordmark logo with the Android app icon on title and
closing slides. Last slide tagline is now "Powered by Team Genesis".

Co-authored-by: arena-agent <297053741+arena-agent@users.noreply.github.com>
</commit_message>
<xml_diff>
--- a/Tourism_Team_Genesis.pptx
+++ b/Tourism_Team_Genesis.pptx
@@ -3228,7 +3228,7 @@
       </p:sp>
       <p:pic>
         <p:nvPicPr>
-          <p:cNvPr id="5" name="Picture 4" descr="logo.png"/>
+          <p:cNvPr id="5" name="Picture 4" descr="app_logo.png"/>
           <p:cNvPicPr>
             <a:picLocks noChangeAspect="1"/>
           </p:cNvPicPr>
@@ -3242,8 +3242,8 @@
         </p:blipFill>
         <p:spPr>
           <a:xfrm>
-            <a:off x="502920" y="365760"/>
-            <a:ext cx="1051560" cy="1051560"/>
+            <a:off x="502920" y="320040"/>
+            <a:ext cx="1234440" cy="1234440"/>
           </a:xfrm>
           <a:prstGeom prst="rect">
             <a:avLst/>
@@ -4037,7 +4037,7 @@
       </p:sp>
       <p:pic>
         <p:nvPicPr>
-          <p:cNvPr id="4" name="Picture 3" descr="logo.png"/>
+          <p:cNvPr id="4" name="Picture 3" descr="app_logo.png"/>
           <p:cNvPicPr>
             <a:picLocks noChangeAspect="1"/>
           </p:cNvPicPr>
@@ -4051,8 +4051,8 @@
         </p:blipFill>
         <p:spPr>
           <a:xfrm>
-            <a:off x="5394960" y="640080"/>
-            <a:ext cx="1325880" cy="1325880"/>
+            <a:off x="5349240" y="502920"/>
+            <a:ext cx="1463040" cy="1463040"/>
           </a:xfrm>
           <a:prstGeom prst="rect">
             <a:avLst/>
@@ -4067,7 +4067,7 @@
         </p:nvSpPr>
         <p:spPr>
           <a:xfrm>
-            <a:off x="731520" y="2103120"/>
+            <a:off x="731520" y="2148840"/>
             <a:ext cx="10698480" cy="320040"/>
           </a:xfrm>
           <a:prstGeom prst="rect">
@@ -4102,7 +4102,7 @@
         </p:nvSpPr>
         <p:spPr>
           <a:xfrm>
-            <a:off x="731520" y="2514600"/>
+            <a:off x="731520" y="2560320"/>
             <a:ext cx="10698480" cy="640080"/>
           </a:xfrm>
           <a:prstGeom prst="rect">
@@ -4137,7 +4137,7 @@
         </p:nvSpPr>
         <p:spPr>
           <a:xfrm>
-            <a:off x="731520" y="3200400"/>
+            <a:off x="731520" y="3246120"/>
             <a:ext cx="10698480" cy="365760"/>
           </a:xfrm>
           <a:prstGeom prst="rect">
@@ -4159,7 +4159,7 @@
                 </a:solidFill>
                 <a:latin typeface="Calibri"/>
               </a:rPr>
-              <a:t>Explore  ·  Travel Safe  ·  Powered by AI</a:t>
+              <a:t>Explore  ·  Travel Safe  ·  Powered by Team Genesis</a:t>
             </a:r>
           </a:p>
         </p:txBody>
@@ -4172,7 +4172,7 @@
         </p:nvSpPr>
         <p:spPr>
           <a:xfrm>
-            <a:off x="3108960" y="3931920"/>
+            <a:off x="3108960" y="3977639"/>
             <a:ext cx="5943600" cy="1554480"/>
           </a:xfrm>
           <a:prstGeom prst="roundRect">
@@ -4217,7 +4217,7 @@
         </p:nvSpPr>
         <p:spPr>
           <a:xfrm>
-            <a:off x="3108960" y="4114800"/>
+            <a:off x="3108960" y="4160520"/>
             <a:ext cx="5943600" cy="274320"/>
           </a:xfrm>
           <a:prstGeom prst="rect">
@@ -4252,7 +4252,7 @@
         </p:nvSpPr>
         <p:spPr>
           <a:xfrm>
-            <a:off x="3108960" y="4434840"/>
+            <a:off x="3108960" y="4480560"/>
             <a:ext cx="5943600" cy="457200"/>
           </a:xfrm>
           <a:prstGeom prst="rect">
@@ -4287,7 +4287,7 @@
         </p:nvSpPr>
         <p:spPr>
           <a:xfrm>
-            <a:off x="3108960" y="4983480"/>
+            <a:off x="3108960" y="5029200"/>
             <a:ext cx="5943600" cy="274320"/>
           </a:xfrm>
           <a:prstGeom prst="rect">

</xml_diff>